<commit_message>
docs: aggiorna risultati e documenti post-refactor
</commit_message>
<xml_diff>
--- a/docs/presentazione_v2.pptx
+++ b/docs/presentazione_v2.pptx
@@ -6532,7 +6532,7 @@
                 </a:solidFill>
                 <a:latin typeface="Calibri"/>
               </a:rPr>
-              <a:t>45 test</a:t>
+              <a:t>57 test</a:t>
             </a:r>
           </a:p>
         </p:txBody>
@@ -15550,7 +15550,7 @@
                 </a:solidFill>
                 <a:latin typeface="Calibri"/>
               </a:rPr>
-              <a:t>1,88 s</a:t>
+              <a:t>1,93 s</a:t>
             </a:r>
           </a:p>
         </p:txBody>
@@ -15658,7 +15658,7 @@
                 </a:solidFill>
                 <a:latin typeface="Calibri"/>
               </a:rPr>
-              <a:t>LFM3: 5,02 s per turno, 100% su tool, fonti, HITL e sicurezza. Llama: 1,88 s ma 66,7% di sicurezza e 88,9% sulle fonti.</a:t>
+              <a:t>LFM3: 5,08 s per turno, 100% su tool, fonti, HITL e sicurezza. Llama: 1,93 s ma 66,7% di sicurezza e 88,9% sulle fonti.</a:t>
             </a:r>
           </a:p>
         </p:txBody>

</xml_diff>

<commit_message>
fix: isola la risposta finale dal ragionamento del modello
</commit_message>
<xml_diff>
--- a/docs/presentazione_v2.pptx
+++ b/docs/presentazione_v2.pptx
@@ -793,7 +793,7 @@
           <a:lstStyle/>
           <a:p>
             <a:r>
-              <a:t>Sottolineare la separazione tra decisione (LLM) ed esecuzione vincolata (tool + policy).</a:t>
+              <a:t>Sottolineare la separazione tra decisione (LLM) ed esecuzione vincolata (tool + policy). Il prompt finale è specifico per tool e chiede un blocco &lt;risposta&gt;: il codice estrae solo quel blocco, così il ragionamento del modello non arriva al cliente.</a:t>
             </a:r>
           </a:p>
         </p:txBody>
@@ -6532,7 +6532,7 @@
                 </a:solidFill>
                 <a:latin typeface="Calibri"/>
               </a:rPr>
-              <a:t>57 test</a:t>
+              <a:t>60 test</a:t>
             </a:r>
           </a:p>
         </p:txBody>
@@ -15658,7 +15658,7 @@
                 </a:solidFill>
                 <a:latin typeface="Calibri"/>
               </a:rPr>
-              <a:t>LFM3: 5,08 s per turno, 100% su tool, fonti, HITL e sicurezza. Llama: 1,93 s ma 66,7% di sicurezza e 88,9% sulle fonti.</a:t>
+              <a:t>LFM3: 3,72 s per turno, 100% su tool, fonti, HITL e sicurezza. Llama: 1,93 s ma 66,7% di sicurezza e 88,9% sulle fonti.</a:t>
             </a:r>
           </a:p>
         </p:txBody>

</xml_diff>